<commit_message>
feat: implementado modal de cadastro de agendamentos & refact: ajustado grid da agenda para permitir criacao de eventos por click
</commit_message>
<xml_diff>
--- a/docs/apresentacao/AgendAI Profissional.pptx
+++ b/docs/apresentacao/AgendAI Profissional.pptx
@@ -120,6 +120,11 @@
       </a:defRPr>
     </a:lvl9pPr>
   </p:defaultTextStyle>
+  <p:extLst>
+    <p:ext uri="{EFAFB233-063F-42B5-8137-9DF3F51BA10A}">
+      <p15:sldGuideLst xmlns:p15="http://schemas.microsoft.com/office/powerpoint/2012/main"/>
+    </p:ext>
+  </p:extLst>
 </p:presentation>
 </file>
 
@@ -3822,173 +3827,6 @@
                 <a:cs typeface="Arial"/>
               </a:rPr>
               <a:t>Integrações e responsabilidade da API</a:t>
-            </a:r>
-          </a:p>
-        </p:txBody>
-      </p:sp>
-      <p:sp>
-        <p:nvSpPr>
-          <p:cNvPr id="2" name="Retângulo 1">
-            <a:extLst>
-              <a:ext uri="{FF2B5EF4-FFF2-40B4-BE49-F238E27FC236}">
-                <a16:creationId xmlns:a16="http://schemas.microsoft.com/office/drawing/2014/main" id="{758BD37F-0431-400E-9257-86D671D42FD2}"/>
-              </a:ext>
-            </a:extLst>
-          </p:cNvPr>
-          <p:cNvSpPr>
-            <a:spLocks noGrp="1"/>
-          </p:cNvSpPr>
-          <p:nvPr/>
-        </p:nvSpPr>
-        <p:spPr>
-          <a:xfrm>
-            <a:off x="628650" y="1232535"/>
-            <a:ext cx="10477500" cy="323850"/>
-          </a:xfrm>
-          <a:prstGeom prst="rect">
-            <a:avLst/>
-          </a:prstGeom>
-          <a:noFill/>
-          <a:ln w="0">
-            <a:noFill/>
-          </a:ln>
-        </p:spPr>
-        <p:txBody>
-          <a:bodyPr wrap="square" anchor="t">
-            <a:noAutofit/>
-          </a:bodyPr>
-          <a:lstStyle/>
-          <a:p>
-            <a:pPr algn="l">
-              <a:defRPr sz="1425" b="0">
-                <a:solidFill>
-                  <a:srgbClr val="62717A"/>
-                </a:solidFill>
-                <a:latin typeface="Arial"/>
-                <a:ea typeface="Arial"/>
-                <a:cs typeface="Arial"/>
-              </a:defRPr>
-            </a:pPr>
-            <a:r>
-              <a:rPr sz="1425" b="0" dirty="0">
-                <a:solidFill>
-                  <a:srgbClr val="62717A"/>
-                </a:solidFill>
-                <a:latin typeface="Arial"/>
-                <a:ea typeface="Arial"/>
-                <a:cs typeface="Arial"/>
-              </a:rPr>
-              <a:t>O </a:t>
-            </a:r>
-            <a:r>
-              <a:rPr sz="1425" b="0" dirty="0" err="1">
-                <a:solidFill>
-                  <a:srgbClr val="62717A"/>
-                </a:solidFill>
-                <a:latin typeface="Arial"/>
-                <a:ea typeface="Arial"/>
-                <a:cs typeface="Arial"/>
-              </a:rPr>
-              <a:t>aplicativo</a:t>
-            </a:r>
-            <a:r>
-              <a:rPr sz="1425" b="0" dirty="0">
-                <a:solidFill>
-                  <a:srgbClr val="62717A"/>
-                </a:solidFill>
-                <a:latin typeface="Arial"/>
-                <a:ea typeface="Arial"/>
-                <a:cs typeface="Arial"/>
-              </a:rPr>
-              <a:t> </a:t>
-            </a:r>
-            <a:r>
-              <a:rPr sz="1425" b="0" dirty="0" err="1">
-                <a:solidFill>
-                  <a:srgbClr val="62717A"/>
-                </a:solidFill>
-                <a:latin typeface="Arial"/>
-                <a:ea typeface="Arial"/>
-                <a:cs typeface="Arial"/>
-              </a:rPr>
-              <a:t>consome</a:t>
-            </a:r>
-            <a:r>
-              <a:rPr sz="1425" b="0" dirty="0">
-                <a:solidFill>
-                  <a:srgbClr val="62717A"/>
-                </a:solidFill>
-                <a:latin typeface="Arial"/>
-                <a:ea typeface="Arial"/>
-                <a:cs typeface="Arial"/>
-              </a:rPr>
-              <a:t> </a:t>
-            </a:r>
-            <a:r>
-              <a:rPr sz="1425" b="0" dirty="0" err="1">
-                <a:solidFill>
-                  <a:srgbClr val="62717A"/>
-                </a:solidFill>
-                <a:latin typeface="Arial"/>
-                <a:ea typeface="Arial"/>
-                <a:cs typeface="Arial"/>
-              </a:rPr>
-              <a:t>uma</a:t>
-            </a:r>
-            <a:r>
-              <a:rPr sz="1425" b="0" dirty="0">
-                <a:solidFill>
-                  <a:srgbClr val="62717A"/>
-                </a:solidFill>
-                <a:latin typeface="Arial"/>
-                <a:ea typeface="Arial"/>
-                <a:cs typeface="Arial"/>
-              </a:rPr>
-              <a:t> </a:t>
-            </a:r>
-            <a:r>
-              <a:rPr sz="1425" b="0" dirty="0" err="1">
-                <a:solidFill>
-                  <a:srgbClr val="62717A"/>
-                </a:solidFill>
-                <a:latin typeface="Arial"/>
-                <a:ea typeface="Arial"/>
-                <a:cs typeface="Arial"/>
-              </a:rPr>
-              <a:t>única</a:t>
-            </a:r>
-            <a:r>
-              <a:rPr sz="1425" b="0" dirty="0">
-                <a:solidFill>
-                  <a:srgbClr val="62717A"/>
-                </a:solidFill>
-                <a:latin typeface="Arial"/>
-                <a:ea typeface="Arial"/>
-                <a:cs typeface="Arial"/>
-              </a:rPr>
-              <a:t> </a:t>
-            </a:r>
-            <a:r>
-              <a:rPr sz="1425" b="0" dirty="0" err="1">
-                <a:solidFill>
-                  <a:srgbClr val="62717A"/>
-                </a:solidFill>
-                <a:latin typeface="Arial"/>
-                <a:ea typeface="Arial"/>
-                <a:cs typeface="Arial"/>
-              </a:rPr>
-              <a:t>fronteira</a:t>
-            </a:r>
-            <a:r>
-              <a:rPr sz="1425" b="0" dirty="0">
-                <a:solidFill>
-                  <a:srgbClr val="62717A"/>
-                </a:solidFill>
-                <a:latin typeface="Arial"/>
-                <a:ea typeface="Arial"/>
-                <a:cs typeface="Arial"/>
-              </a:rPr>
-              <a:t> por HTTPS e JSON</a:t>
             </a:r>
           </a:p>
         </p:txBody>
@@ -14302,7 +14140,13 @@
         <p:nvGraphicFramePr>
           <p:cNvPr id="12" name="Tabela 11"/>
           <p:cNvGraphicFramePr/>
-          <p:nvPr/>
+          <p:nvPr>
+            <p:extLst>
+              <p:ext uri="{D42A27DB-BD31-4B8C-83A1-F6EECF244321}">
+                <p14:modId xmlns:p14="http://schemas.microsoft.com/office/powerpoint/2010/main" val="2590382052"/>
+              </p:ext>
+            </p:extLst>
+          </p:nvPr>
         </p:nvGraphicFramePr>
         <p:xfrm>
           <a:off x="647700" y="1428750"/>
@@ -14469,7 +14313,7 @@
                     <a:lstStyle/>
                     <a:p>
                       <a:r>
-                        <a:rPr sz="1425">
+                        <a:rPr sz="1425" dirty="0">
                           <a:solidFill>
                             <a:srgbClr val="131B2E"/>
                           </a:solidFill>
@@ -14477,7 +14321,95 @@
                           <a:ea typeface="Arial"/>
                           <a:cs typeface="Arial"/>
                         </a:rPr>
-                        <a:t>Interface multiplataforma, navegação, sessão local e consumo da API</a:t>
+                        <a:t>Interface </a:t>
+                      </a:r>
+                      <a:r>
+                        <a:rPr lang="pt-BR" sz="1425" dirty="0">
+                          <a:solidFill>
+                            <a:srgbClr val="131B2E"/>
+                          </a:solidFill>
+                          <a:latin typeface="Arial"/>
+                          <a:ea typeface="Arial"/>
+                          <a:cs typeface="Arial"/>
+                        </a:rPr>
+                        <a:t>mobile</a:t>
+                      </a:r>
+                      <a:r>
+                        <a:rPr sz="1425" dirty="0">
+                          <a:solidFill>
+                            <a:srgbClr val="131B2E"/>
+                          </a:solidFill>
+                          <a:latin typeface="Arial"/>
+                          <a:ea typeface="Arial"/>
+                          <a:cs typeface="Arial"/>
+                        </a:rPr>
+                        <a:t>, </a:t>
+                      </a:r>
+                      <a:r>
+                        <a:rPr sz="1425" dirty="0" err="1">
+                          <a:solidFill>
+                            <a:srgbClr val="131B2E"/>
+                          </a:solidFill>
+                          <a:latin typeface="Arial"/>
+                          <a:ea typeface="Arial"/>
+                          <a:cs typeface="Arial"/>
+                        </a:rPr>
+                        <a:t>navegação</a:t>
+                      </a:r>
+                      <a:r>
+                        <a:rPr sz="1425" dirty="0">
+                          <a:solidFill>
+                            <a:srgbClr val="131B2E"/>
+                          </a:solidFill>
+                          <a:latin typeface="Arial"/>
+                          <a:ea typeface="Arial"/>
+                          <a:cs typeface="Arial"/>
+                        </a:rPr>
+                        <a:t>, </a:t>
+                      </a:r>
+                      <a:r>
+                        <a:rPr sz="1425" dirty="0" err="1">
+                          <a:solidFill>
+                            <a:srgbClr val="131B2E"/>
+                          </a:solidFill>
+                          <a:latin typeface="Arial"/>
+                          <a:ea typeface="Arial"/>
+                          <a:cs typeface="Arial"/>
+                        </a:rPr>
+                        <a:t>sessão</a:t>
+                      </a:r>
+                      <a:r>
+                        <a:rPr sz="1425" dirty="0">
+                          <a:solidFill>
+                            <a:srgbClr val="131B2E"/>
+                          </a:solidFill>
+                          <a:latin typeface="Arial"/>
+                          <a:ea typeface="Arial"/>
+                          <a:cs typeface="Arial"/>
+                        </a:rPr>
+                        <a:t> local e </a:t>
+                      </a:r>
+                      <a:r>
+                        <a:rPr sz="1425" dirty="0" err="1">
+                          <a:solidFill>
+                            <a:srgbClr val="131B2E"/>
+                          </a:solidFill>
+                          <a:latin typeface="Arial"/>
+                          <a:ea typeface="Arial"/>
+                          <a:cs typeface="Arial"/>
+                        </a:rPr>
+                        <a:t>consumo</a:t>
+                      </a:r>
+                      <a:r>
+                        <a:rPr sz="1425" dirty="0">
+                          <a:solidFill>
+                            <a:srgbClr val="131B2E"/>
+                          </a:solidFill>
+                          <a:latin typeface="Arial"/>
+                          <a:ea typeface="Arial"/>
+                          <a:cs typeface="Arial"/>
+                        </a:rPr>
+                        <a:t> da API</a:t>
                       </a:r>
                     </a:p>
                   </a:txBody>

</xml_diff>